<commit_message>
Cut consumer-spending risk; respace slide to four risks
Co-Authored-By: Claude Opus 5.5 <noreply@anthropic.com>
Claude-Session: https://claude.ai/code/session_01Cj79ASkpMEuE6e5NkxXNtw
</commit_message>
<xml_diff>
--- a/DKS_Risks_Mitigants.pptx
+++ b/DKS_Risks_Mitigants.pptx
@@ -1072,8 +1072,8 @@
         </p:nvSpPr>
         <p:spPr>
           <a:xfrm>
-            <a:off x="36576" y="1453896"/>
-            <a:ext cx="2615184" cy="530352"/>
+            <a:off x="36576" y="1481328"/>
+            <a:ext cx="2615184" cy="603504"/>
           </a:xfrm>
           <a:prstGeom prst="homePlate">
             <a:avLst/>
@@ -1163,7 +1163,7 @@
         <p:spPr>
           <a:xfrm>
             <a:off x="2788920" y="1581912"/>
-            <a:ext cx="1600200" cy="457200"/>
+            <a:ext cx="1600200" cy="585216"/>
           </a:xfrm>
           <a:prstGeom prst="rect">
             <a:avLst/>
@@ -1207,7 +1207,7 @@
         </p:nvSpPr>
         <p:spPr>
           <a:xfrm>
-            <a:off x="4425696" y="1810512"/>
+            <a:off x="4425696" y="1874520"/>
             <a:ext cx="219456" cy="0"/>
           </a:xfrm>
           <a:prstGeom prst="line">
@@ -1276,7 +1276,7 @@
         <p:spPr>
           <a:xfrm>
             <a:off x="4681728" y="1581912"/>
-            <a:ext cx="4416552" cy="457200"/>
+            <a:ext cx="4416552" cy="585216"/>
           </a:xfrm>
           <a:prstGeom prst="rect">
             <a:avLst/>
@@ -1298,7 +1298,7 @@
               <a:buNone/>
             </a:pPr>
             <a:r>
-              <a:rPr lang="en-US" sz="850" dirty="0">
+              <a:rPr lang="en-US" sz="950" dirty="0">
                 <a:solidFill>
                   <a:srgbClr val="1B2644"/>
                 </a:solidFill>
@@ -1308,7 +1308,7 @@
               </a:rPr>
               <a:t>13 of 20 House of Sport stores (65%) say attraction users rarely buy, and 15 of 20 (75%) see traffic fading since opening. Q3 FY26 earnings (late Nov) test comps once conversion lift is stripped out.</a:t>
             </a:r>
-            <a:endParaRPr lang="en-US" sz="850" dirty="0"/>
+            <a:endParaRPr lang="en-US" sz="950" dirty="0"/>
           </a:p>
         </p:txBody>
       </p:sp>
@@ -1320,7 +1320,7 @@
         </p:nvSpPr>
         <p:spPr>
           <a:xfrm>
-            <a:off x="2743200" y="2066544"/>
+            <a:off x="2743200" y="2217420"/>
             <a:ext cx="6400800" cy="0"/>
           </a:xfrm>
           <a:prstGeom prst="line">
@@ -1343,8 +1343,8 @@
         </p:nvSpPr>
         <p:spPr>
           <a:xfrm>
-            <a:off x="36576" y="2157984"/>
-            <a:ext cx="2615184" cy="530352"/>
+            <a:off x="36576" y="2359152"/>
+            <a:ext cx="2615184" cy="603504"/>
           </a:xfrm>
           <a:prstGeom prst="homePlate">
             <a:avLst/>
@@ -1388,7 +1388,7 @@
         </p:nvSpPr>
         <p:spPr>
           <a:xfrm>
-            <a:off x="2788920" y="2093976"/>
+            <a:off x="2788920" y="2267712"/>
             <a:ext cx="1600200" cy="155448"/>
           </a:xfrm>
           <a:prstGeom prst="rect">
@@ -1433,8 +1433,8 @@
         </p:nvSpPr>
         <p:spPr>
           <a:xfrm>
-            <a:off x="2788920" y="2286000"/>
-            <a:ext cx="1600200" cy="457200"/>
+            <a:off x="2788920" y="2459736"/>
+            <a:ext cx="1600200" cy="585216"/>
           </a:xfrm>
           <a:prstGeom prst="rect">
             <a:avLst/>
@@ -1478,7 +1478,7 @@
         </p:nvSpPr>
         <p:spPr>
           <a:xfrm>
-            <a:off x="4425696" y="2514600"/>
+            <a:off x="4425696" y="2752344"/>
             <a:ext cx="219456" cy="0"/>
           </a:xfrm>
           <a:prstGeom prst="line">
@@ -1501,7 +1501,7 @@
         </p:nvSpPr>
         <p:spPr>
           <a:xfrm>
-            <a:off x="4681728" y="2093976"/>
+            <a:off x="4681728" y="2267712"/>
             <a:ext cx="4416552" cy="155448"/>
           </a:xfrm>
           <a:prstGeom prst="rect">
@@ -1546,8 +1546,8 @@
         </p:nvSpPr>
         <p:spPr>
           <a:xfrm>
-            <a:off x="4681728" y="2286000"/>
-            <a:ext cx="4416552" cy="457200"/>
+            <a:off x="4681728" y="2459736"/>
+            <a:ext cx="4416552" cy="585216"/>
           </a:xfrm>
           <a:prstGeom prst="rect">
             <a:avLst/>
@@ -1569,7 +1569,7 @@
               <a:buNone/>
             </a:pPr>
             <a:r>
-              <a:rPr lang="en-US" sz="850" dirty="0">
+              <a:rPr lang="en-US" sz="950" dirty="0">
                 <a:solidFill>
                   <a:srgbClr val="1B2644"/>
                 </a:solidFill>
@@ -1579,7 +1579,7 @@
               </a:rPr>
               <a:t>~36 more House of Sport and Field House openings are planned for FY26, so reinvestment is structural; even at normal investment, cash trails the EPS-implied path by ~$500M. FY27 capex guide (Mar 2027) confirms.</a:t>
             </a:r>
-            <a:endParaRPr lang="en-US" sz="850" dirty="0"/>
+            <a:endParaRPr lang="en-US" sz="950" dirty="0"/>
           </a:p>
         </p:txBody>
       </p:sp>
@@ -1591,7 +1591,7 @@
         </p:nvSpPr>
         <p:spPr>
           <a:xfrm>
-            <a:off x="2743200" y="2770632"/>
+            <a:off x="2743200" y="3095244"/>
             <a:ext cx="6400800" cy="0"/>
           </a:xfrm>
           <a:prstGeom prst="line">
@@ -1614,8 +1614,8 @@
         </p:nvSpPr>
         <p:spPr>
           <a:xfrm>
-            <a:off x="36576" y="2862072"/>
-            <a:ext cx="2615184" cy="530352"/>
+            <a:off x="36576" y="3236976"/>
+            <a:ext cx="2615184" cy="603504"/>
           </a:xfrm>
           <a:prstGeom prst="homePlate">
             <a:avLst/>
@@ -1659,7 +1659,7 @@
         </p:nvSpPr>
         <p:spPr>
           <a:xfrm>
-            <a:off x="2788920" y="2798064"/>
+            <a:off x="2788920" y="3145536"/>
             <a:ext cx="1600200" cy="155448"/>
           </a:xfrm>
           <a:prstGeom prst="rect">
@@ -1704,8 +1704,8 @@
         </p:nvSpPr>
         <p:spPr>
           <a:xfrm>
-            <a:off x="2788920" y="2990088"/>
-            <a:ext cx="1600200" cy="457200"/>
+            <a:off x="2788920" y="3337560"/>
+            <a:ext cx="1600200" cy="585216"/>
           </a:xfrm>
           <a:prstGeom prst="rect">
             <a:avLst/>
@@ -1749,7 +1749,7 @@
         </p:nvSpPr>
         <p:spPr>
           <a:xfrm>
-            <a:off x="4425696" y="3218688"/>
+            <a:off x="4425696" y="3630168"/>
             <a:ext cx="219456" cy="0"/>
           </a:xfrm>
           <a:prstGeom prst="line">
@@ -1772,7 +1772,7 @@
         </p:nvSpPr>
         <p:spPr>
           <a:xfrm>
-            <a:off x="4681728" y="2798064"/>
+            <a:off x="4681728" y="3145536"/>
             <a:ext cx="4416552" cy="155448"/>
           </a:xfrm>
           <a:prstGeom prst="rect">
@@ -1817,8 +1817,8 @@
         </p:nvSpPr>
         <p:spPr>
           <a:xfrm>
-            <a:off x="4681728" y="2990088"/>
-            <a:ext cx="4416552" cy="457200"/>
+            <a:off x="4681728" y="3337560"/>
+            <a:ext cx="4416552" cy="585216"/>
           </a:xfrm>
           <a:prstGeom prst="rect">
             <a:avLst/>
@@ -1840,7 +1840,7 @@
               <a:buNone/>
             </a:pPr>
             <a:r>
-              <a:rPr lang="en-US" sz="850" dirty="0">
+              <a:rPr lang="en-US" sz="950" dirty="0">
                 <a:solidFill>
                   <a:srgbClr val="1B2644"/>
                 </a:solidFill>
@@ -1850,7 +1850,7 @@
               </a:rPr>
               <a:t>Nike's North American wholesale grew 9% while total revenue fell 4%, so sell-in is outpacing demand. With 61% of Nike sales via wholesale, Nike FQ2 (Dec 2026) and holiday markdowns show where excess lands.</a:t>
             </a:r>
-            <a:endParaRPr lang="en-US" sz="850" dirty="0"/>
+            <a:endParaRPr lang="en-US" sz="950" dirty="0"/>
           </a:p>
         </p:txBody>
       </p:sp>
@@ -1862,7 +1862,7 @@
         </p:nvSpPr>
         <p:spPr>
           <a:xfrm>
-            <a:off x="2743200" y="3474720"/>
+            <a:off x="2743200" y="3973068"/>
             <a:ext cx="6400800" cy="0"/>
           </a:xfrm>
           <a:prstGeom prst="line">
@@ -1885,8 +1885,8 @@
         </p:nvSpPr>
         <p:spPr>
           <a:xfrm>
-            <a:off x="36576" y="3566160"/>
-            <a:ext cx="2615184" cy="530352"/>
+            <a:off x="36576" y="4114800"/>
+            <a:ext cx="2615184" cy="603504"/>
           </a:xfrm>
           <a:prstGeom prst="homePlate">
             <a:avLst/>
@@ -1916,7 +1916,7 @@
                 <a:ea typeface="Garamond" pitchFamily="34" charset="-122"/>
                 <a:cs typeface="Garamond" pitchFamily="34" charset="-120"/>
               </a:rPr>
-              <a:t>Consumer Spending Proves Resilient</a:t>
+              <a:t>Foot Locker Turnaround Beats Expectations</a:t>
             </a:r>
             <a:endParaRPr lang="en-US" sz="1050" dirty="0"/>
           </a:p>
@@ -1930,7 +1930,7 @@
         </p:nvSpPr>
         <p:spPr>
           <a:xfrm>
-            <a:off x="2788920" y="3502152"/>
+            <a:off x="2788920" y="4023360"/>
             <a:ext cx="1600200" cy="155448"/>
           </a:xfrm>
           <a:prstGeom prst="rect">
@@ -1975,8 +1975,8 @@
         </p:nvSpPr>
         <p:spPr>
           <a:xfrm>
-            <a:off x="2788920" y="3694176"/>
-            <a:ext cx="1600200" cy="457200"/>
+            <a:off x="2788920" y="4215384"/>
+            <a:ext cx="1600200" cy="585216"/>
           </a:xfrm>
           <a:prstGeom prst="rect">
             <a:avLst/>
@@ -2006,7 +2006,7 @@
                 <a:ea typeface="Garamond" pitchFamily="34" charset="-122"/>
                 <a:cs typeface="Garamond" pitchFamily="34" charset="-120"/>
               </a:rPr>
-              <a:t>Medium</a:t>
+              <a:t>High</a:t>
             </a:r>
             <a:endParaRPr lang="en-US" sz="1700" dirty="0"/>
           </a:p>
@@ -2020,7 +2020,7 @@
         </p:nvSpPr>
         <p:spPr>
           <a:xfrm>
-            <a:off x="4425696" y="3922776"/>
+            <a:off x="4425696" y="4507992"/>
             <a:ext cx="219456" cy="0"/>
           </a:xfrm>
           <a:prstGeom prst="line">
@@ -2043,7 +2043,7 @@
         </p:nvSpPr>
         <p:spPr>
           <a:xfrm>
-            <a:off x="4681728" y="3502152"/>
+            <a:off x="4681728" y="4023360"/>
             <a:ext cx="4416552" cy="155448"/>
           </a:xfrm>
           <a:prstGeom prst="rect">
@@ -2088,8 +2088,8 @@
         </p:nvSpPr>
         <p:spPr>
           <a:xfrm>
-            <a:off x="4681728" y="3694176"/>
-            <a:ext cx="4416552" cy="457200"/>
+            <a:off x="4681728" y="4215384"/>
+            <a:ext cx="4416552" cy="585216"/>
           </a:xfrm>
           <a:prstGeom prst="rect">
             <a:avLst/>
@@ -2111,7 +2111,7 @@
               <a:buNone/>
             </a:pPr>
             <a:r>
-              <a:rPr lang="en-US" sz="850" dirty="0">
+              <a:rPr lang="en-US" sz="950" dirty="0">
                 <a:solidFill>
                   <a:srgbClr val="1B2644"/>
                 </a:solidFill>
@@ -2119,286 +2119,15 @@
                 <a:ea typeface="Garamond" pitchFamily="34" charset="-122"/>
                 <a:cs typeface="Garamond" pitchFamily="34" charset="-120"/>
               </a:rPr>
-              <a:t>Retail spending is holding up on higher prices, not volume: item counts are falling and legacy-store traffic declined 0.6% (Advan). Holiday 2026 unit trends and Q4 FY26 comps (Mar 2027) test this.</a:t>
-            </a:r>
-            <a:endParaRPr lang="en-US" sz="850" dirty="0"/>
-          </a:p>
-        </p:txBody>
-      </p:sp>
-      <p:sp>
-        <p:nvSpPr>
-          <p:cNvPr id="35" name="Divider 4"/>
-          <p:cNvSpPr/>
-          <p:nvPr/>
-        </p:nvSpPr>
-        <p:spPr>
-          <a:xfrm>
-            <a:off x="2743200" y="4178808"/>
-            <a:ext cx="6400800" cy="0"/>
-          </a:xfrm>
-          <a:prstGeom prst="line">
-            <a:avLst/>
-          </a:prstGeom>
-          <a:noFill/>
-          <a:ln w="9525">
-            <a:solidFill>
-              <a:srgbClr val="001746"/>
-            </a:solidFill>
-            <a:prstDash val="solid"/>
-          </a:ln>
-        </p:spPr>
-      </p:sp>
-      <p:sp>
-        <p:nvSpPr>
-          <p:cNvPr id="36" name="Risk 5"/>
-          <p:cNvSpPr/>
-          <p:nvPr/>
-        </p:nvSpPr>
-        <p:spPr>
-          <a:xfrm>
-            <a:off x="36576" y="4270248"/>
-            <a:ext cx="2615184" cy="530352"/>
-          </a:xfrm>
-          <a:prstGeom prst="homePlate">
-            <a:avLst/>
-          </a:prstGeom>
-          <a:solidFill>
-            <a:srgbClr val="FFFFFF"/>
-          </a:solidFill>
-          <a:ln w="22225">
-            <a:solidFill>
-              <a:srgbClr val="1F3864"/>
-            </a:solidFill>
-          </a:ln>
-        </p:spPr>
-        <p:txBody>
-          <a:bodyPr wrap="square" lIns="76200" tIns="76200" rIns="76200" bIns="76200" rtlCol="0" anchor="ctr"/>
-          <a:lstStyle/>
-          <a:p>
-            <a:pPr algn="ctr" indent="0" marL="0">
-              <a:buNone/>
-            </a:pPr>
-            <a:r>
-              <a:rPr lang="en-US" sz="1050" dirty="0">
-                <a:solidFill>
-                  <a:srgbClr val="262626"/>
-                </a:solidFill>
-                <a:latin typeface="Garamond" pitchFamily="34" charset="0"/>
-                <a:ea typeface="Garamond" pitchFamily="34" charset="-122"/>
-                <a:cs typeface="Garamond" pitchFamily="34" charset="-120"/>
-              </a:rPr>
-              <a:t>Foot Locker Turnaround Beats Expectations</a:t>
-            </a:r>
-            <a:endParaRPr lang="en-US" sz="1050" dirty="0"/>
-          </a:p>
-        </p:txBody>
-      </p:sp>
-      <p:sp>
-        <p:nvSpPr>
-          <p:cNvPr id="37" name="Level header 5"/>
-          <p:cNvSpPr/>
-          <p:nvPr/>
-        </p:nvSpPr>
-        <p:spPr>
-          <a:xfrm>
-            <a:off x="2788920" y="4206240"/>
-            <a:ext cx="1600200" cy="155448"/>
-          </a:xfrm>
-          <a:prstGeom prst="rect">
-            <a:avLst/>
-          </a:prstGeom>
-          <a:solidFill>
-            <a:srgbClr val="001746"/>
-          </a:solidFill>
-          <a:ln>
-            <a:solidFill>
-              <a:srgbClr val="001746"/>
-            </a:solidFill>
-          </a:ln>
-        </p:spPr>
-        <p:txBody>
-          <a:bodyPr wrap="square" lIns="0" tIns="0" rIns="0" bIns="0" rtlCol="0" anchor="ctr"/>
-          <a:lstStyle/>
-          <a:p>
-            <a:pPr algn="ctr" indent="0" marL="0">
-              <a:buNone/>
-            </a:pPr>
-            <a:r>
-              <a:rPr lang="en-US" sz="900" dirty="0">
-                <a:solidFill>
-                  <a:srgbClr val="FFFFFF"/>
-                </a:solidFill>
-                <a:latin typeface="Garamond" pitchFamily="34" charset="0"/>
-                <a:ea typeface="Garamond" pitchFamily="34" charset="-122"/>
-                <a:cs typeface="Garamond" pitchFamily="34" charset="-120"/>
-              </a:rPr>
-              <a:t>Level of Risk</a:t>
-            </a:r>
-            <a:endParaRPr lang="en-US" sz="900" dirty="0"/>
-          </a:p>
-        </p:txBody>
-      </p:sp>
-      <p:sp>
-        <p:nvSpPr>
-          <p:cNvPr id="38" name="Level 5"/>
-          <p:cNvSpPr/>
-          <p:nvPr/>
-        </p:nvSpPr>
-        <p:spPr>
-          <a:xfrm>
-            <a:off x="2788920" y="4398264"/>
-            <a:ext cx="1600200" cy="457200"/>
-          </a:xfrm>
-          <a:prstGeom prst="rect">
-            <a:avLst/>
-          </a:prstGeom>
-          <a:solidFill>
-            <a:srgbClr val="002060"/>
-          </a:solidFill>
-          <a:ln w="12700">
-            <a:solidFill>
-              <a:srgbClr val="E4E9F0"/>
-            </a:solidFill>
-          </a:ln>
-        </p:spPr>
-        <p:txBody>
-          <a:bodyPr wrap="square" lIns="0" tIns="0" rIns="0" bIns="0" rtlCol="0" anchor="ctr"/>
-          <a:lstStyle/>
-          <a:p>
-            <a:pPr algn="ctr" indent="0" marL="0">
-              <a:buNone/>
-            </a:pPr>
-            <a:r>
-              <a:rPr lang="en-US" sz="1700" b="1" dirty="0">
-                <a:solidFill>
-                  <a:srgbClr val="FFFFFF"/>
-                </a:solidFill>
-                <a:latin typeface="Garamond" pitchFamily="34" charset="0"/>
-                <a:ea typeface="Garamond" pitchFamily="34" charset="-122"/>
-                <a:cs typeface="Garamond" pitchFamily="34" charset="-120"/>
-              </a:rPr>
-              <a:t>High</a:t>
-            </a:r>
-            <a:endParaRPr lang="en-US" sz="1700" dirty="0"/>
-          </a:p>
-        </p:txBody>
-      </p:sp>
-      <p:sp>
-        <p:nvSpPr>
-          <p:cNvPr id="39" name="Connector 5"/>
-          <p:cNvSpPr/>
-          <p:nvPr/>
-        </p:nvSpPr>
-        <p:spPr>
-          <a:xfrm>
-            <a:off x="4425696" y="4626864"/>
-            <a:ext cx="219456" cy="0"/>
-          </a:xfrm>
-          <a:prstGeom prst="line">
-            <a:avLst/>
-          </a:prstGeom>
-          <a:noFill/>
-          <a:ln w="15875">
-            <a:solidFill>
-              <a:srgbClr val="BFBFBF"/>
-            </a:solidFill>
-            <a:prstDash val="sysDot"/>
-          </a:ln>
-        </p:spPr>
-      </p:sp>
-      <p:sp>
-        <p:nvSpPr>
-          <p:cNvPr id="40" name="Mitigant header 5"/>
-          <p:cNvSpPr/>
-          <p:nvPr/>
-        </p:nvSpPr>
-        <p:spPr>
-          <a:xfrm>
-            <a:off x="4681728" y="4206240"/>
-            <a:ext cx="4416552" cy="155448"/>
-          </a:xfrm>
-          <a:prstGeom prst="rect">
-            <a:avLst/>
-          </a:prstGeom>
-          <a:solidFill>
-            <a:srgbClr val="001746"/>
-          </a:solidFill>
-          <a:ln>
-            <a:solidFill>
-              <a:srgbClr val="001746"/>
-            </a:solidFill>
-          </a:ln>
-        </p:spPr>
-        <p:txBody>
-          <a:bodyPr wrap="square" lIns="0" tIns="0" rIns="0" bIns="0" rtlCol="0" anchor="ctr"/>
-          <a:lstStyle/>
-          <a:p>
-            <a:pPr algn="ctr" indent="0" marL="0">
-              <a:buNone/>
-            </a:pPr>
-            <a:r>
-              <a:rPr lang="en-US" sz="900" dirty="0">
-                <a:solidFill>
-                  <a:srgbClr val="FFFFFF"/>
-                </a:solidFill>
-                <a:latin typeface="Garamond" pitchFamily="34" charset="0"/>
-                <a:ea typeface="Garamond" pitchFamily="34" charset="-122"/>
-                <a:cs typeface="Garamond" pitchFamily="34" charset="-120"/>
-              </a:rPr>
-              <a:t>Mitigant:</a:t>
-            </a:r>
-            <a:endParaRPr lang="en-US" sz="900" dirty="0"/>
-          </a:p>
-        </p:txBody>
-      </p:sp>
-      <p:sp>
-        <p:nvSpPr>
-          <p:cNvPr id="41" name="Mitigant 5"/>
-          <p:cNvSpPr/>
-          <p:nvPr/>
-        </p:nvSpPr>
-        <p:spPr>
-          <a:xfrm>
-            <a:off x="4681728" y="4398264"/>
-            <a:ext cx="4416552" cy="457200"/>
-          </a:xfrm>
-          <a:prstGeom prst="rect">
-            <a:avLst/>
-          </a:prstGeom>
-          <a:solidFill>
-            <a:srgbClr val="E4E9F0"/>
-          </a:solidFill>
-          <a:ln>
-            <a:solidFill>
-              <a:srgbClr val="E4E9F0"/>
-            </a:solidFill>
-          </a:ln>
-        </p:spPr>
-        <p:txBody>
-          <a:bodyPr wrap="square" lIns="0" tIns="63500" rIns="63500" bIns="0" rtlCol="0" anchor="ctr"/>
-          <a:lstStyle/>
-          <a:p>
-            <a:pPr algn="ctr" indent="0" marL="0">
-              <a:buNone/>
-            </a:pPr>
-            <a:r>
-              <a:rPr lang="en-US" sz="850" dirty="0">
-                <a:solidFill>
-                  <a:srgbClr val="1B2644"/>
-                </a:solidFill>
-                <a:latin typeface="Garamond" pitchFamily="34" charset="0"/>
-                <a:ea typeface="Garamond" pitchFamily="34" charset="-122"/>
-                <a:cs typeface="Garamond" pitchFamily="34" charset="-120"/>
-              </a:rPr>
               <a:t>Foot Locker needs $142.1M of added profit to support a $13.15 EPS recovery, and a 10% discount on 15% of its sales erases $74.5M (52%) of that. It enters the comp base in Q4 FY26, guided –2% to 0%.</a:t>
             </a:r>
-            <a:endParaRPr lang="en-US" sz="850" dirty="0"/>
-          </a:p>
-        </p:txBody>
-      </p:sp>
-      <p:sp>
-        <p:nvSpPr>
-          <p:cNvPr id="42" name="Headwinds label"/>
+            <a:endParaRPr lang="en-US" sz="950" dirty="0"/>
+          </a:p>
+        </p:txBody>
+      </p:sp>
+      <p:sp>
+        <p:nvSpPr>
+          <p:cNvPr id="35" name="Headwinds label"/>
           <p:cNvSpPr txBox="1"/>
           <p:nvPr/>
         </p:nvSpPr>
@@ -2437,7 +2166,7 @@
       </p:sp>
       <p:sp>
         <p:nvSpPr>
-          <p:cNvPr id="43" name="Headwinds rule"/>
+          <p:cNvPr id="36" name="Headwinds rule"/>
           <p:cNvSpPr/>
           <p:nvPr/>
         </p:nvSpPr>
@@ -2460,7 +2189,7 @@
       </p:sp>
       <p:sp>
         <p:nvSpPr>
-          <p:cNvPr id="44" name="Headwinds callout"/>
+          <p:cNvPr id="37" name="Headwinds callout"/>
           <p:cNvSpPr/>
           <p:nvPr/>
         </p:nvSpPr>
@@ -2526,7 +2255,7 @@
       </p:sp>
       <p:sp>
         <p:nvSpPr>
-          <p:cNvPr id="45" name="Tailwinds label"/>
+          <p:cNvPr id="38" name="Tailwinds label"/>
           <p:cNvSpPr txBox="1"/>
           <p:nvPr/>
         </p:nvSpPr>
@@ -2565,7 +2294,7 @@
       </p:sp>
       <p:sp>
         <p:nvSpPr>
-          <p:cNvPr id="46" name="Tailwinds rule"/>
+          <p:cNvPr id="39" name="Tailwinds rule"/>
           <p:cNvSpPr/>
           <p:nvPr/>
         </p:nvSpPr>
@@ -2588,7 +2317,7 @@
       </p:sp>
       <p:sp>
         <p:nvSpPr>
-          <p:cNvPr id="47" name="Tailwinds callout"/>
+          <p:cNvPr id="40" name="Tailwinds callout"/>
           <p:cNvSpPr/>
           <p:nvPr/>
         </p:nvSpPr>

</xml_diff>